<commit_message>
Improve PPT layout to match original banner design
- Add hydrangea SVG decorations at top corners
- Fix layout proportions to match original
- Improve placeholder styling for missing photos

Co-Authored-By: Claude Opus 4.6 <noreply@anthropic.com>
Claude-Session: https://claude.ai/code/session_01CTSqfJq8bHqRGATA6DEpij
</commit_message>
<xml_diff>
--- a/retirement-banner.pptx
+++ b/retirement-banner.pptx
@@ -7,7 +7,7 @@
   <p:sldIdLst>
     <p:sldId id="256" r:id="rId7"/>
   </p:sldIdLst>
-  <p:sldSz cx="12191695" cy="6858000" type="screen4x3"/>
+  <p:sldSz cx="14630400" cy="8229600" type="screen4x3"/>
   <p:notesSz cx="6858000" cy="9144000"/>
   <p:defaultTextStyle>
     <a:defPPr>
@@ -3098,57 +3098,23 @@
       <p:grpSpPr/>
       <p:sp>
         <p:nvSpPr>
-          <p:cNvPr id="2" name="TextBox 1"/>
-          <p:cNvSpPr txBox="1"/>
+          <p:cNvPr id="2" name="Rectangle 1"/>
+          <p:cNvSpPr/>
           <p:nvPr/>
         </p:nvSpPr>
         <p:spPr>
           <a:xfrm>
-            <a:off x="1371600" y="1097280"/>
-            <a:ext cx="9448495" cy="731520"/>
+            <a:off x="91440" y="91440"/>
+            <a:ext cx="14447520" cy="8046720"/>
           </a:xfrm>
           <a:prstGeom prst="rect">
             <a:avLst/>
           </a:prstGeom>
           <a:noFill/>
-        </p:spPr>
-        <p:txBody>
-          <a:bodyPr wrap="square">
-            <a:spAutoFit/>
-          </a:bodyPr>
-          <a:lstStyle/>
-          <a:p>
-            <a:pPr algn="ctr"/>
-            <a:r>
-              <a:rPr sz="3600" b="1">
-                <a:solidFill>
-                  <a:srgbClr val="7B4020"/>
-                </a:solidFill>
-              </a:rPr>
-              <a:t>신세계 강남점  ·  상반기 정년퇴임 기념</a:t>
-            </a:r>
-          </a:p>
-        </p:txBody>
-      </p:sp>
-      <p:sp>
-        <p:nvSpPr>
-          <p:cNvPr id="3" name="Rectangle 2"/>
-          <p:cNvSpPr/>
-          <p:nvPr/>
-        </p:nvSpPr>
-        <p:spPr>
-          <a:xfrm>
-            <a:off x="2743200" y="1965960"/>
-            <a:ext cx="6705295" cy="12700"/>
-          </a:xfrm>
-          <a:prstGeom prst="rect">
-            <a:avLst/>
-          </a:prstGeom>
-          <a:solidFill>
-            <a:srgbClr val="C9853A"/>
-          </a:solidFill>
-          <a:ln>
-            <a:noFill/>
+          <a:ln w="9525">
+            <a:solidFill>
+              <a:srgbClr val="D4A030"/>
+            </a:solidFill>
           </a:ln>
         </p:spPr>
         <p:style>
@@ -3173,16 +3139,64 @@
           </a:p>
         </p:txBody>
       </p:sp>
-      <p:sp>
-        <p:nvSpPr>
-          <p:cNvPr id="4" name="TextBox 3"/>
+      <p:pic>
+        <p:nvPicPr>
+          <p:cNvPr id="3" name="Picture 2" descr="svg_deco_0.png"/>
+          <p:cNvPicPr>
+            <a:picLocks noChangeAspect="1"/>
+          </p:cNvPicPr>
+          <p:nvPr/>
+        </p:nvPicPr>
+        <p:blipFill>
+          <a:blip r:embed="rId2"/>
+          <a:stretch>
+            <a:fillRect/>
+          </a:stretch>
+        </p:blipFill>
+        <p:spPr>
+          <a:xfrm>
+            <a:off x="0" y="0"/>
+            <a:ext cx="2926080" cy="2560320"/>
+          </a:xfrm>
+          <a:prstGeom prst="rect">
+            <a:avLst/>
+          </a:prstGeom>
+        </p:spPr>
+      </p:pic>
+      <p:pic>
+        <p:nvPicPr>
+          <p:cNvPr id="4" name="Picture 3" descr="svg_deco_1.png"/>
+          <p:cNvPicPr>
+            <a:picLocks noChangeAspect="1"/>
+          </p:cNvPicPr>
+          <p:nvPr/>
+        </p:nvPicPr>
+        <p:blipFill>
+          <a:blip r:embed="rId3"/>
+          <a:stretch>
+            <a:fillRect/>
+          </a:stretch>
+        </p:blipFill>
+        <p:spPr>
+          <a:xfrm>
+            <a:off x="11704320" y="0"/>
+            <a:ext cx="2926080" cy="2560320"/>
+          </a:xfrm>
+          <a:prstGeom prst="rect">
+            <a:avLst/>
+          </a:prstGeom>
+        </p:spPr>
+      </p:pic>
+      <p:sp>
+        <p:nvSpPr>
+          <p:cNvPr id="5" name="TextBox 4"/>
           <p:cNvSpPr txBox="1"/>
           <p:nvPr/>
         </p:nvSpPr>
         <p:spPr>
           <a:xfrm>
-            <a:off x="5669280" y="1783080"/>
-            <a:ext cx="822960" cy="365760"/>
+            <a:off x="2743200" y="914400"/>
+            <a:ext cx="9144000" cy="822960"/>
           </a:xfrm>
           <a:prstGeom prst="rect">
             <a:avLst/>
@@ -3190,68 +3204,19 @@
           <a:noFill/>
         </p:spPr>
         <p:txBody>
-          <a:bodyPr wrap="none">
-            <a:spAutoFit/>
-          </a:bodyPr>
-          <a:lstStyle/>
-          <a:p>
-            <a:pPr algn="ctr"/>
-            <a:r>
-              <a:rPr sz="2000">
-                <a:solidFill>
-                  <a:srgbClr val="C9853A"/>
-                </a:solidFill>
-              </a:rPr>
-              <a:t>✿</a:t>
-            </a:r>
-          </a:p>
-        </p:txBody>
-      </p:sp>
-      <p:sp>
-        <p:nvSpPr>
-          <p:cNvPr id="5" name="TextBox 4"/>
-          <p:cNvSpPr txBox="1"/>
-          <p:nvPr/>
-        </p:nvSpPr>
-        <p:spPr>
-          <a:xfrm>
-            <a:off x="1371600" y="2286000"/>
-            <a:ext cx="9448495" cy="1097280"/>
-          </a:xfrm>
-          <a:prstGeom prst="rect">
-            <a:avLst/>
-          </a:prstGeom>
-          <a:noFill/>
-        </p:spPr>
-        <p:txBody>
           <a:bodyPr wrap="square">
             <a:spAutoFit/>
           </a:bodyPr>
           <a:lstStyle/>
           <a:p>
-            <a:pPr algn="ctr">
-              <a:spcAft>
-                <a:spcPts val="800"/>
-              </a:spcAft>
-            </a:pPr>
-            <a:r>
-              <a:rPr sz="2400">
+            <a:pPr algn="ctr"/>
+            <a:r>
+              <a:rPr sz="4000" b="1">
                 <a:solidFill>
-                  <a:srgbClr val="6B4A28"/>
+                  <a:srgbClr val="7B4020"/>
                 </a:solidFill>
               </a:rPr>
-              <a:t>그동안 함께해 주셔서 정말 고마웠습니다</a:t>
-            </a:r>
-          </a:p>
-          <a:p>
-            <a:pPr algn="ctr"/>
-            <a:r>
-              <a:rPr sz="2400">
-                <a:solidFill>
-                  <a:srgbClr val="6B4A28"/>
-                </a:solidFill>
-              </a:rPr>
-              <a:t>감사한 마음을 담아 특식을 준비했습니다  ·  맛있게 드세요!</a:t>
+              <a:t>신세계 강남점  ·  상반기 정년퇴임 기념</a:t>
             </a:r>
           </a:p>
         </p:txBody>
@@ -3264,14 +3229,14 @@
         </p:nvSpPr>
         <p:spPr>
           <a:xfrm>
-            <a:off x="0" y="3840480"/>
-            <a:ext cx="12191695" cy="3017520"/>
+            <a:off x="3840480" y="2011680"/>
+            <a:ext cx="3017520" cy="12700"/>
           </a:xfrm>
           <a:prstGeom prst="rect">
             <a:avLst/>
           </a:prstGeom>
           <a:solidFill>
-            <a:srgbClr val="FAE8C2"/>
+            <a:srgbClr val="C9853A"/>
           </a:solidFill>
           <a:ln>
             <a:noFill/>
@@ -3307,8 +3272,8 @@
         </p:nvSpPr>
         <p:spPr>
           <a:xfrm>
-            <a:off x="1234440" y="4023360"/>
-            <a:ext cx="1645920" cy="320040"/>
+            <a:off x="6903720" y="1828800"/>
+            <a:ext cx="822960" cy="411480"/>
           </a:xfrm>
           <a:prstGeom prst="rect">
             <a:avLst/>
@@ -3323,7 +3288,219 @@
           <a:p>
             <a:pPr algn="ctr"/>
             <a:r>
-              <a:rPr sz="1200" b="1">
+              <a:rPr sz="2000">
+                <a:solidFill>
+                  <a:srgbClr val="C9853A"/>
+                </a:solidFill>
+              </a:rPr>
+              <a:t>✿</a:t>
+            </a:r>
+          </a:p>
+        </p:txBody>
+      </p:sp>
+      <p:sp>
+        <p:nvSpPr>
+          <p:cNvPr id="8" name="Rectangle 7"/>
+          <p:cNvSpPr/>
+          <p:nvPr/>
+        </p:nvSpPr>
+        <p:spPr>
+          <a:xfrm>
+            <a:off x="7772400" y="2011680"/>
+            <a:ext cx="3017520" cy="12700"/>
+          </a:xfrm>
+          <a:prstGeom prst="rect">
+            <a:avLst/>
+          </a:prstGeom>
+          <a:solidFill>
+            <a:srgbClr val="C9853A"/>
+          </a:solidFill>
+          <a:ln>
+            <a:noFill/>
+          </a:ln>
+        </p:spPr>
+        <p:style>
+          <a:lnRef idx="1">
+            <a:schemeClr val="accent1"/>
+          </a:lnRef>
+          <a:fillRef idx="3">
+            <a:schemeClr val="accent1"/>
+          </a:fillRef>
+          <a:effectRef idx="2">
+            <a:schemeClr val="accent1"/>
+          </a:effectRef>
+          <a:fontRef idx="minor">
+            <a:schemeClr val="lt1"/>
+          </a:fontRef>
+        </p:style>
+        <p:txBody>
+          <a:bodyPr rtlCol="0" anchor="ctr"/>
+          <a:lstStyle/>
+          <a:p>
+            <a:pPr algn="ctr"/>
+          </a:p>
+        </p:txBody>
+      </p:sp>
+      <p:sp>
+        <p:nvSpPr>
+          <p:cNvPr id="9" name="TextBox 8"/>
+          <p:cNvSpPr txBox="1"/>
+          <p:nvPr/>
+        </p:nvSpPr>
+        <p:spPr>
+          <a:xfrm>
+            <a:off x="2743200" y="2468880"/>
+            <a:ext cx="9144000" cy="1280160"/>
+          </a:xfrm>
+          <a:prstGeom prst="rect">
+            <a:avLst/>
+          </a:prstGeom>
+          <a:noFill/>
+        </p:spPr>
+        <p:txBody>
+          <a:bodyPr wrap="square">
+            <a:spAutoFit/>
+          </a:bodyPr>
+          <a:lstStyle/>
+          <a:p>
+            <a:pPr algn="ctr">
+              <a:spcAft>
+                <a:spcPts val="1400"/>
+              </a:spcAft>
+            </a:pPr>
+            <a:r>
+              <a:rPr sz="2600">
+                <a:solidFill>
+                  <a:srgbClr val="6B4A28"/>
+                </a:solidFill>
+              </a:rPr>
+              <a:t>그동안 함께해 주셔서 정말 고마웠습니다</a:t>
+            </a:r>
+          </a:p>
+          <a:p>
+            <a:pPr algn="ctr"/>
+            <a:r>
+              <a:rPr sz="2600">
+                <a:solidFill>
+                  <a:srgbClr val="6B4A28"/>
+                </a:solidFill>
+              </a:rPr>
+              <a:t>감사한 마음을 담아 특식을 준비했습니다  ·  맛있게 드세요!</a:t>
+            </a:r>
+          </a:p>
+        </p:txBody>
+      </p:sp>
+      <p:sp>
+        <p:nvSpPr>
+          <p:cNvPr id="10" name="Rectangle 9"/>
+          <p:cNvSpPr/>
+          <p:nvPr/>
+        </p:nvSpPr>
+        <p:spPr>
+          <a:xfrm>
+            <a:off x="0" y="4114800"/>
+            <a:ext cx="14630400" cy="4114800"/>
+          </a:xfrm>
+          <a:prstGeom prst="rect">
+            <a:avLst/>
+          </a:prstGeom>
+          <a:solidFill>
+            <a:srgbClr val="FAE8C2"/>
+          </a:solidFill>
+          <a:ln>
+            <a:noFill/>
+          </a:ln>
+        </p:spPr>
+        <p:style>
+          <a:lnRef idx="1">
+            <a:schemeClr val="accent1"/>
+          </a:lnRef>
+          <a:fillRef idx="3">
+            <a:schemeClr val="accent1"/>
+          </a:fillRef>
+          <a:effectRef idx="2">
+            <a:schemeClr val="accent1"/>
+          </a:effectRef>
+          <a:fontRef idx="minor">
+            <a:schemeClr val="lt1"/>
+          </a:fontRef>
+        </p:style>
+        <p:txBody>
+          <a:bodyPr rtlCol="0" anchor="ctr"/>
+          <a:lstStyle/>
+          <a:p>
+            <a:pPr algn="ctr"/>
+          </a:p>
+        </p:txBody>
+      </p:sp>
+      <p:sp>
+        <p:nvSpPr>
+          <p:cNvPr id="11" name="Rectangle 10"/>
+          <p:cNvSpPr/>
+          <p:nvPr/>
+        </p:nvSpPr>
+        <p:spPr>
+          <a:xfrm>
+            <a:off x="0" y="4114800"/>
+            <a:ext cx="14630400" cy="12700"/>
+          </a:xfrm>
+          <a:prstGeom prst="rect">
+            <a:avLst/>
+          </a:prstGeom>
+          <a:solidFill>
+            <a:srgbClr val="E8C07A"/>
+          </a:solidFill>
+          <a:ln>
+            <a:noFill/>
+          </a:ln>
+        </p:spPr>
+        <p:style>
+          <a:lnRef idx="1">
+            <a:schemeClr val="accent1"/>
+          </a:lnRef>
+          <a:fillRef idx="3">
+            <a:schemeClr val="accent1"/>
+          </a:fillRef>
+          <a:effectRef idx="2">
+            <a:schemeClr val="accent1"/>
+          </a:effectRef>
+          <a:fontRef idx="minor">
+            <a:schemeClr val="lt1"/>
+          </a:fontRef>
+        </p:style>
+        <p:txBody>
+          <a:bodyPr rtlCol="0" anchor="ctr"/>
+          <a:lstStyle/>
+          <a:p>
+            <a:pPr algn="ctr"/>
+          </a:p>
+        </p:txBody>
+      </p:sp>
+      <p:sp>
+        <p:nvSpPr>
+          <p:cNvPr id="12" name="TextBox 11"/>
+          <p:cNvSpPr txBox="1"/>
+          <p:nvPr/>
+        </p:nvSpPr>
+        <p:spPr>
+          <a:xfrm>
+            <a:off x="1645919" y="4343400"/>
+            <a:ext cx="1097280" cy="320040"/>
+          </a:xfrm>
+          <a:prstGeom prst="rect">
+            <a:avLst/>
+          </a:prstGeom>
+          <a:noFill/>
+        </p:spPr>
+        <p:txBody>
+          <a:bodyPr wrap="none">
+            <a:spAutoFit/>
+          </a:bodyPr>
+          <a:lstStyle/>
+          <a:p>
+            <a:pPr algn="ctr"/>
+            <a:r>
+              <a:rPr sz="1100" b="1">
                 <a:solidFill>
                   <a:srgbClr val="B87020"/>
                 </a:solidFill>
@@ -3335,327 +3512,7 @@
       </p:sp>
       <p:pic>
         <p:nvPicPr>
-          <p:cNvPr id="8" name="Picture 7" descr="person_0.png"/>
-          <p:cNvPicPr>
-            <a:picLocks noChangeAspect="1"/>
-          </p:cNvPicPr>
-          <p:nvPr/>
-        </p:nvPicPr>
-        <p:blipFill>
-          <a:blip r:embed="rId2"/>
-          <a:stretch>
-            <a:fillRect/>
-          </a:stretch>
-        </p:blipFill>
-        <p:spPr>
-          <a:xfrm>
-            <a:off x="1371600" y="4434840"/>
-            <a:ext cx="1371600" cy="1371600"/>
-          </a:xfrm>
-          <a:prstGeom prst="rect">
-            <a:avLst/>
-          </a:prstGeom>
-        </p:spPr>
-      </p:pic>
-      <p:sp>
-        <p:nvSpPr>
-          <p:cNvPr id="9" name="TextBox 8"/>
-          <p:cNvSpPr txBox="1"/>
-          <p:nvPr/>
-        </p:nvSpPr>
-        <p:spPr>
-          <a:xfrm>
-            <a:off x="1234440" y="5852160"/>
-            <a:ext cx="1645920" cy="274320"/>
-          </a:xfrm>
-          <a:prstGeom prst="rect">
-            <a:avLst/>
-          </a:prstGeom>
-          <a:noFill/>
-        </p:spPr>
-        <p:txBody>
-          <a:bodyPr wrap="none">
-            <a:spAutoFit/>
-          </a:bodyPr>
-          <a:lstStyle/>
-          <a:p>
-            <a:pPr algn="ctr"/>
-            <a:r>
-              <a:rPr sz="1800" b="1">
-                <a:solidFill>
-                  <a:srgbClr val="2C1508"/>
-                </a:solidFill>
-              </a:rPr>
-              <a:t>김보영</a:t>
-            </a:r>
-          </a:p>
-        </p:txBody>
-      </p:sp>
-      <p:sp>
-        <p:nvSpPr>
-          <p:cNvPr id="10" name="TextBox 9"/>
-          <p:cNvSpPr txBox="1"/>
-          <p:nvPr/>
-        </p:nvSpPr>
-        <p:spPr>
-          <a:xfrm>
-            <a:off x="1234440" y="6126480"/>
-            <a:ext cx="1645920" cy="274320"/>
-          </a:xfrm>
-          <a:prstGeom prst="rect">
-            <a:avLst/>
-          </a:prstGeom>
-          <a:noFill/>
-        </p:spPr>
-        <p:txBody>
-          <a:bodyPr wrap="none">
-            <a:spAutoFit/>
-          </a:bodyPr>
-          <a:lstStyle/>
-          <a:p>
-            <a:pPr algn="ctr"/>
-            <a:r>
-              <a:rPr sz="1300" b="0">
-                <a:solidFill>
-                  <a:srgbClr val="9B7340"/>
-                </a:solidFill>
-              </a:rPr>
-              <a:t>파트너님</a:t>
-            </a:r>
-          </a:p>
-        </p:txBody>
-      </p:sp>
-      <p:sp>
-        <p:nvSpPr>
-          <p:cNvPr id="11" name="TextBox 10"/>
-          <p:cNvSpPr txBox="1"/>
-          <p:nvPr/>
-        </p:nvSpPr>
-        <p:spPr>
-          <a:xfrm>
-            <a:off x="1234440" y="6355080"/>
-            <a:ext cx="1645920" cy="274320"/>
-          </a:xfrm>
-          <a:prstGeom prst="rect">
-            <a:avLst/>
-          </a:prstGeom>
-          <a:noFill/>
-        </p:spPr>
-        <p:txBody>
-          <a:bodyPr wrap="none">
-            <a:spAutoFit/>
-          </a:bodyPr>
-          <a:lstStyle/>
-          <a:p>
-            <a:pPr algn="ctr"/>
-            <a:r>
-              <a:rPr sz="1200" b="1">
-                <a:solidFill>
-                  <a:srgbClr val="C9853A"/>
-                </a:solidFill>
-              </a:rPr>
-              <a:t>23년 1개월</a:t>
-            </a:r>
-          </a:p>
-        </p:txBody>
-      </p:sp>
-      <p:sp>
-        <p:nvSpPr>
-          <p:cNvPr id="12" name="TextBox 11"/>
-          <p:cNvSpPr txBox="1"/>
-          <p:nvPr/>
-        </p:nvSpPr>
-        <p:spPr>
-          <a:xfrm>
-            <a:off x="3246120" y="4023360"/>
-            <a:ext cx="1645920" cy="320040"/>
-          </a:xfrm>
-          <a:prstGeom prst="rect">
-            <a:avLst/>
-          </a:prstGeom>
-          <a:noFill/>
-        </p:spPr>
-        <p:txBody>
-          <a:bodyPr wrap="none">
-            <a:spAutoFit/>
-          </a:bodyPr>
-          <a:lstStyle/>
-          <a:p>
-            <a:pPr algn="ctr"/>
-            <a:r>
-              <a:rPr sz="1200" b="1">
-                <a:solidFill>
-                  <a:srgbClr val="B87020"/>
-                </a:solidFill>
-              </a:rPr>
-              <a:t>POP운영팀</a:t>
-            </a:r>
-          </a:p>
-        </p:txBody>
-      </p:sp>
-      <p:pic>
-        <p:nvPicPr>
-          <p:cNvPr id="13" name="Picture 12" descr="person_1.png"/>
-          <p:cNvPicPr>
-            <a:picLocks noChangeAspect="1"/>
-          </p:cNvPicPr>
-          <p:nvPr/>
-        </p:nvPicPr>
-        <p:blipFill>
-          <a:blip r:embed="rId3"/>
-          <a:stretch>
-            <a:fillRect/>
-          </a:stretch>
-        </p:blipFill>
-        <p:spPr>
-          <a:xfrm>
-            <a:off x="3383280" y="4434840"/>
-            <a:ext cx="1371600" cy="1371600"/>
-          </a:xfrm>
-          <a:prstGeom prst="rect">
-            <a:avLst/>
-          </a:prstGeom>
-        </p:spPr>
-      </p:pic>
-      <p:sp>
-        <p:nvSpPr>
-          <p:cNvPr id="14" name="TextBox 13"/>
-          <p:cNvSpPr txBox="1"/>
-          <p:nvPr/>
-        </p:nvSpPr>
-        <p:spPr>
-          <a:xfrm>
-            <a:off x="3246120" y="5852160"/>
-            <a:ext cx="1645920" cy="274320"/>
-          </a:xfrm>
-          <a:prstGeom prst="rect">
-            <a:avLst/>
-          </a:prstGeom>
-          <a:noFill/>
-        </p:spPr>
-        <p:txBody>
-          <a:bodyPr wrap="none">
-            <a:spAutoFit/>
-          </a:bodyPr>
-          <a:lstStyle/>
-          <a:p>
-            <a:pPr algn="ctr"/>
-            <a:r>
-              <a:rPr sz="1800" b="1">
-                <a:solidFill>
-                  <a:srgbClr val="2C1508"/>
-                </a:solidFill>
-              </a:rPr>
-              <a:t>전은영</a:t>
-            </a:r>
-          </a:p>
-        </p:txBody>
-      </p:sp>
-      <p:sp>
-        <p:nvSpPr>
-          <p:cNvPr id="15" name="TextBox 14"/>
-          <p:cNvSpPr txBox="1"/>
-          <p:nvPr/>
-        </p:nvSpPr>
-        <p:spPr>
-          <a:xfrm>
-            <a:off x="3246120" y="6126480"/>
-            <a:ext cx="1645920" cy="274320"/>
-          </a:xfrm>
-          <a:prstGeom prst="rect">
-            <a:avLst/>
-          </a:prstGeom>
-          <a:noFill/>
-        </p:spPr>
-        <p:txBody>
-          <a:bodyPr wrap="none">
-            <a:spAutoFit/>
-          </a:bodyPr>
-          <a:lstStyle/>
-          <a:p>
-            <a:pPr algn="ctr"/>
-            <a:r>
-              <a:rPr sz="1300" b="0">
-                <a:solidFill>
-                  <a:srgbClr val="9B7340"/>
-                </a:solidFill>
-              </a:rPr>
-              <a:t>파트너님</a:t>
-            </a:r>
-          </a:p>
-        </p:txBody>
-      </p:sp>
-      <p:sp>
-        <p:nvSpPr>
-          <p:cNvPr id="16" name="TextBox 15"/>
-          <p:cNvSpPr txBox="1"/>
-          <p:nvPr/>
-        </p:nvSpPr>
-        <p:spPr>
-          <a:xfrm>
-            <a:off x="3246120" y="6355080"/>
-            <a:ext cx="1645920" cy="274320"/>
-          </a:xfrm>
-          <a:prstGeom prst="rect">
-            <a:avLst/>
-          </a:prstGeom>
-          <a:noFill/>
-        </p:spPr>
-        <p:txBody>
-          <a:bodyPr wrap="none">
-            <a:spAutoFit/>
-          </a:bodyPr>
-          <a:lstStyle/>
-          <a:p>
-            <a:pPr algn="ctr"/>
-            <a:r>
-              <a:rPr sz="1200" b="1">
-                <a:solidFill>
-                  <a:srgbClr val="C9853A"/>
-                </a:solidFill>
-              </a:rPr>
-              <a:t>16년 8개월</a:t>
-            </a:r>
-          </a:p>
-        </p:txBody>
-      </p:sp>
-      <p:sp>
-        <p:nvSpPr>
-          <p:cNvPr id="17" name="TextBox 16"/>
-          <p:cNvSpPr txBox="1"/>
-          <p:nvPr/>
-        </p:nvSpPr>
-        <p:spPr>
-          <a:xfrm>
-            <a:off x="5257800" y="4023360"/>
-            <a:ext cx="1645920" cy="320040"/>
-          </a:xfrm>
-          <a:prstGeom prst="rect">
-            <a:avLst/>
-          </a:prstGeom>
-          <a:noFill/>
-        </p:spPr>
-        <p:txBody>
-          <a:bodyPr wrap="none">
-            <a:spAutoFit/>
-          </a:bodyPr>
-          <a:lstStyle/>
-          <a:p>
-            <a:pPr algn="ctr"/>
-            <a:r>
-              <a:rPr sz="1200" b="1">
-                <a:solidFill>
-                  <a:srgbClr val="B87020"/>
-                </a:solidFill>
-              </a:rPr>
-              <a:t>POP운영팀</a:t>
-            </a:r>
-          </a:p>
-        </p:txBody>
-      </p:sp>
-      <p:pic>
-        <p:nvPicPr>
-          <p:cNvPr id="18" name="Picture 17" descr="person_2.png"/>
+          <p:cNvPr id="13" name="Picture 12" descr="person_final_0.png"/>
           <p:cNvPicPr>
             <a:picLocks noChangeAspect="1"/>
           </p:cNvPicPr>
@@ -3669,8 +3526,8 @@
         </p:blipFill>
         <p:spPr>
           <a:xfrm>
-            <a:off x="5394960" y="4434840"/>
-            <a:ext cx="1371600" cy="1371600"/>
+            <a:off x="1371600" y="4754880"/>
+            <a:ext cx="1645920" cy="1645920"/>
           </a:xfrm>
           <a:prstGeom prst="rect">
             <a:avLst/>
@@ -3679,14 +3536,14 @@
       </p:pic>
       <p:sp>
         <p:nvSpPr>
-          <p:cNvPr id="19" name="TextBox 18"/>
+          <p:cNvPr id="14" name="TextBox 13"/>
           <p:cNvSpPr txBox="1"/>
           <p:nvPr/>
         </p:nvSpPr>
         <p:spPr>
           <a:xfrm>
-            <a:off x="5257800" y="5852160"/>
-            <a:ext cx="1645920" cy="274320"/>
+            <a:off x="1554480" y="6537960"/>
+            <a:ext cx="1280160" cy="274320"/>
           </a:xfrm>
           <a:prstGeom prst="rect">
             <a:avLst/>
@@ -3701,26 +3558,26 @@
           <a:p>
             <a:pPr algn="ctr"/>
             <a:r>
-              <a:rPr sz="1800" b="1">
+              <a:rPr sz="2000" b="1">
                 <a:solidFill>
                   <a:srgbClr val="2C1508"/>
                 </a:solidFill>
               </a:rPr>
-              <a:t>장정원</a:t>
-            </a:r>
-          </a:p>
-        </p:txBody>
-      </p:sp>
-      <p:sp>
-        <p:nvSpPr>
-          <p:cNvPr id="20" name="TextBox 19"/>
+              <a:t>김보영</a:t>
+            </a:r>
+          </a:p>
+        </p:txBody>
+      </p:sp>
+      <p:sp>
+        <p:nvSpPr>
+          <p:cNvPr id="15" name="TextBox 14"/>
           <p:cNvSpPr txBox="1"/>
           <p:nvPr/>
         </p:nvSpPr>
         <p:spPr>
           <a:xfrm>
-            <a:off x="5257800" y="6126480"/>
-            <a:ext cx="1645920" cy="274320"/>
+            <a:off x="1554480" y="6858000"/>
+            <a:ext cx="1280160" cy="274320"/>
           </a:xfrm>
           <a:prstGeom prst="rect">
             <a:avLst/>
@@ -3735,7 +3592,7 @@
           <a:p>
             <a:pPr algn="ctr"/>
             <a:r>
-              <a:rPr sz="1300" b="0">
+              <a:rPr sz="1400" b="0">
                 <a:solidFill>
                   <a:srgbClr val="9B7340"/>
                 </a:solidFill>
@@ -3747,14 +3604,14 @@
       </p:sp>
       <p:sp>
         <p:nvSpPr>
-          <p:cNvPr id="21" name="TextBox 20"/>
+          <p:cNvPr id="16" name="TextBox 15"/>
           <p:cNvSpPr txBox="1"/>
           <p:nvPr/>
         </p:nvSpPr>
         <p:spPr>
           <a:xfrm>
-            <a:off x="5257800" y="6355080"/>
-            <a:ext cx="1645920" cy="274320"/>
+            <a:off x="1554480" y="7132320"/>
+            <a:ext cx="1280160" cy="274320"/>
           </a:xfrm>
           <a:prstGeom prst="rect">
             <a:avLst/>
@@ -3769,26 +3626,26 @@
           <a:p>
             <a:pPr algn="ctr"/>
             <a:r>
-              <a:rPr sz="1200" b="1">
+              <a:rPr sz="1300" b="1">
                 <a:solidFill>
                   <a:srgbClr val="C9853A"/>
                 </a:solidFill>
               </a:rPr>
-              <a:t>16년 1개월</a:t>
-            </a:r>
-          </a:p>
-        </p:txBody>
-      </p:sp>
-      <p:sp>
-        <p:nvSpPr>
-          <p:cNvPr id="22" name="TextBox 21"/>
+              <a:t>23년 1개월</a:t>
+            </a:r>
+          </a:p>
+        </p:txBody>
+      </p:sp>
+      <p:sp>
+        <p:nvSpPr>
+          <p:cNvPr id="17" name="TextBox 16"/>
           <p:cNvSpPr txBox="1"/>
           <p:nvPr/>
         </p:nvSpPr>
         <p:spPr>
           <a:xfrm>
-            <a:off x="7269480" y="4023360"/>
-            <a:ext cx="1645920" cy="320040"/>
+            <a:off x="4206240" y="4343400"/>
+            <a:ext cx="1097280" cy="320040"/>
           </a:xfrm>
           <a:prstGeom prst="rect">
             <a:avLst/>
@@ -3803,7 +3660,7 @@
           <a:p>
             <a:pPr algn="ctr"/>
             <a:r>
-              <a:rPr sz="1200" b="1">
+              <a:rPr sz="1100" b="1">
                 <a:solidFill>
                   <a:srgbClr val="B87020"/>
                 </a:solidFill>
@@ -3815,22 +3672,22 @@
       </p:sp>
       <p:pic>
         <p:nvPicPr>
-          <p:cNvPr id="23" name="Picture 22" descr="person_2.png"/>
+          <p:cNvPr id="18" name="Picture 17" descr="person_final_1.png"/>
           <p:cNvPicPr>
             <a:picLocks noChangeAspect="1"/>
           </p:cNvPicPr>
           <p:nvPr/>
         </p:nvPicPr>
         <p:blipFill>
-          <a:blip r:embed="rId4"/>
+          <a:blip r:embed="rId5"/>
           <a:stretch>
             <a:fillRect/>
           </a:stretch>
         </p:blipFill>
         <p:spPr>
           <a:xfrm>
-            <a:off x="7406640" y="4434840"/>
-            <a:ext cx="1371600" cy="1371600"/>
+            <a:off x="3931920" y="4754880"/>
+            <a:ext cx="1645920" cy="1645920"/>
           </a:xfrm>
           <a:prstGeom prst="rect">
             <a:avLst/>
@@ -3839,14 +3696,14 @@
       </p:pic>
       <p:sp>
         <p:nvSpPr>
-          <p:cNvPr id="24" name="TextBox 23"/>
+          <p:cNvPr id="19" name="TextBox 18"/>
           <p:cNvSpPr txBox="1"/>
           <p:nvPr/>
         </p:nvSpPr>
         <p:spPr>
           <a:xfrm>
-            <a:off x="7269480" y="5852160"/>
-            <a:ext cx="1645920" cy="274320"/>
+            <a:off x="4114800" y="6537960"/>
+            <a:ext cx="1280160" cy="274320"/>
           </a:xfrm>
           <a:prstGeom prst="rect">
             <a:avLst/>
@@ -3861,26 +3718,26 @@
           <a:p>
             <a:pPr algn="ctr"/>
             <a:r>
-              <a:rPr sz="1800" b="1">
+              <a:rPr sz="2000" b="1">
                 <a:solidFill>
                   <a:srgbClr val="2C1508"/>
                 </a:solidFill>
               </a:rPr>
-              <a:t>제경순</a:t>
-            </a:r>
-          </a:p>
-        </p:txBody>
-      </p:sp>
-      <p:sp>
-        <p:nvSpPr>
-          <p:cNvPr id="25" name="TextBox 24"/>
+              <a:t>전은영</a:t>
+            </a:r>
+          </a:p>
+        </p:txBody>
+      </p:sp>
+      <p:sp>
+        <p:nvSpPr>
+          <p:cNvPr id="20" name="TextBox 19"/>
           <p:cNvSpPr txBox="1"/>
           <p:nvPr/>
         </p:nvSpPr>
         <p:spPr>
           <a:xfrm>
-            <a:off x="7269480" y="6126480"/>
-            <a:ext cx="1645920" cy="274320"/>
+            <a:off x="4114800" y="6858000"/>
+            <a:ext cx="1280160" cy="274320"/>
           </a:xfrm>
           <a:prstGeom prst="rect">
             <a:avLst/>
@@ -3895,7 +3752,7 @@
           <a:p>
             <a:pPr algn="ctr"/>
             <a:r>
-              <a:rPr sz="1300" b="0">
+              <a:rPr sz="1400" b="0">
                 <a:solidFill>
                   <a:srgbClr val="9B7340"/>
                 </a:solidFill>
@@ -3907,14 +3764,14 @@
       </p:sp>
       <p:sp>
         <p:nvSpPr>
-          <p:cNvPr id="26" name="TextBox 25"/>
+          <p:cNvPr id="21" name="TextBox 20"/>
           <p:cNvSpPr txBox="1"/>
           <p:nvPr/>
         </p:nvSpPr>
         <p:spPr>
           <a:xfrm>
-            <a:off x="7269480" y="6355080"/>
-            <a:ext cx="1645920" cy="274320"/>
+            <a:off x="4114800" y="7132320"/>
+            <a:ext cx="1280160" cy="274320"/>
           </a:xfrm>
           <a:prstGeom prst="rect">
             <a:avLst/>
@@ -3929,26 +3786,26 @@
           <a:p>
             <a:pPr algn="ctr"/>
             <a:r>
-              <a:rPr sz="1200" b="1">
+              <a:rPr sz="1300" b="1">
                 <a:solidFill>
                   <a:srgbClr val="C9853A"/>
                 </a:solidFill>
               </a:rPr>
-              <a:t>15년 8개월</a:t>
-            </a:r>
-          </a:p>
-        </p:txBody>
-      </p:sp>
-      <p:sp>
-        <p:nvSpPr>
-          <p:cNvPr id="27" name="TextBox 26"/>
+              <a:t>16년 8개월</a:t>
+            </a:r>
+          </a:p>
+        </p:txBody>
+      </p:sp>
+      <p:sp>
+        <p:nvSpPr>
+          <p:cNvPr id="22" name="TextBox 21"/>
           <p:cNvSpPr txBox="1"/>
           <p:nvPr/>
         </p:nvSpPr>
         <p:spPr>
           <a:xfrm>
-            <a:off x="9281160" y="4023360"/>
-            <a:ext cx="1645920" cy="320040"/>
+            <a:off x="6766560" y="4343400"/>
+            <a:ext cx="1097280" cy="320040"/>
           </a:xfrm>
           <a:prstGeom prst="rect">
             <a:avLst/>
@@ -3963,34 +3820,34 @@
           <a:p>
             <a:pPr algn="ctr"/>
             <a:r>
-              <a:rPr sz="1200" b="1">
+              <a:rPr sz="1100" b="1">
                 <a:solidFill>
                   <a:srgbClr val="B87020"/>
                 </a:solidFill>
               </a:rPr>
-              <a:t>식품팀</a:t>
+              <a:t>POP운영팀</a:t>
             </a:r>
           </a:p>
         </p:txBody>
       </p:sp>
       <p:pic>
         <p:nvPicPr>
-          <p:cNvPr id="28" name="Picture 27" descr="person_2.png"/>
+          <p:cNvPr id="23" name="Picture 22" descr="person_final_2.png"/>
           <p:cNvPicPr>
             <a:picLocks noChangeAspect="1"/>
           </p:cNvPicPr>
           <p:nvPr/>
         </p:nvPicPr>
         <p:blipFill>
-          <a:blip r:embed="rId4"/>
+          <a:blip r:embed="rId6"/>
           <a:stretch>
             <a:fillRect/>
           </a:stretch>
         </p:blipFill>
         <p:spPr>
           <a:xfrm>
-            <a:off x="9418320" y="4434840"/>
-            <a:ext cx="1371600" cy="1371600"/>
+            <a:off x="6492240" y="4754880"/>
+            <a:ext cx="1645920" cy="1645920"/>
           </a:xfrm>
           <a:prstGeom prst="rect">
             <a:avLst/>
@@ -3999,14 +3856,14 @@
       </p:pic>
       <p:sp>
         <p:nvSpPr>
-          <p:cNvPr id="29" name="TextBox 28"/>
+          <p:cNvPr id="24" name="TextBox 23"/>
           <p:cNvSpPr txBox="1"/>
           <p:nvPr/>
         </p:nvSpPr>
         <p:spPr>
           <a:xfrm>
-            <a:off x="9281160" y="5852160"/>
-            <a:ext cx="1645920" cy="274320"/>
+            <a:off x="6675120" y="6537960"/>
+            <a:ext cx="1280160" cy="274320"/>
           </a:xfrm>
           <a:prstGeom prst="rect">
             <a:avLst/>
@@ -4021,7 +3878,327 @@
           <a:p>
             <a:pPr algn="ctr"/>
             <a:r>
-              <a:rPr sz="1800" b="1">
+              <a:rPr sz="2000" b="1">
+                <a:solidFill>
+                  <a:srgbClr val="2C1508"/>
+                </a:solidFill>
+              </a:rPr>
+              <a:t>장정원</a:t>
+            </a:r>
+          </a:p>
+        </p:txBody>
+      </p:sp>
+      <p:sp>
+        <p:nvSpPr>
+          <p:cNvPr id="25" name="TextBox 24"/>
+          <p:cNvSpPr txBox="1"/>
+          <p:nvPr/>
+        </p:nvSpPr>
+        <p:spPr>
+          <a:xfrm>
+            <a:off x="6675120" y="6858000"/>
+            <a:ext cx="1280160" cy="274320"/>
+          </a:xfrm>
+          <a:prstGeom prst="rect">
+            <a:avLst/>
+          </a:prstGeom>
+          <a:noFill/>
+        </p:spPr>
+        <p:txBody>
+          <a:bodyPr wrap="none">
+            <a:spAutoFit/>
+          </a:bodyPr>
+          <a:lstStyle/>
+          <a:p>
+            <a:pPr algn="ctr"/>
+            <a:r>
+              <a:rPr sz="1400" b="0">
+                <a:solidFill>
+                  <a:srgbClr val="9B7340"/>
+                </a:solidFill>
+              </a:rPr>
+              <a:t>파트너님</a:t>
+            </a:r>
+          </a:p>
+        </p:txBody>
+      </p:sp>
+      <p:sp>
+        <p:nvSpPr>
+          <p:cNvPr id="26" name="TextBox 25"/>
+          <p:cNvSpPr txBox="1"/>
+          <p:nvPr/>
+        </p:nvSpPr>
+        <p:spPr>
+          <a:xfrm>
+            <a:off x="6675120" y="7132320"/>
+            <a:ext cx="1280160" cy="274320"/>
+          </a:xfrm>
+          <a:prstGeom prst="rect">
+            <a:avLst/>
+          </a:prstGeom>
+          <a:noFill/>
+        </p:spPr>
+        <p:txBody>
+          <a:bodyPr wrap="none">
+            <a:spAutoFit/>
+          </a:bodyPr>
+          <a:lstStyle/>
+          <a:p>
+            <a:pPr algn="ctr"/>
+            <a:r>
+              <a:rPr sz="1300" b="1">
+                <a:solidFill>
+                  <a:srgbClr val="C9853A"/>
+                </a:solidFill>
+              </a:rPr>
+              <a:t>16년 1개월</a:t>
+            </a:r>
+          </a:p>
+        </p:txBody>
+      </p:sp>
+      <p:sp>
+        <p:nvSpPr>
+          <p:cNvPr id="27" name="TextBox 26"/>
+          <p:cNvSpPr txBox="1"/>
+          <p:nvPr/>
+        </p:nvSpPr>
+        <p:spPr>
+          <a:xfrm>
+            <a:off x="9326880" y="4343400"/>
+            <a:ext cx="1097280" cy="320040"/>
+          </a:xfrm>
+          <a:prstGeom prst="rect">
+            <a:avLst/>
+          </a:prstGeom>
+          <a:noFill/>
+        </p:spPr>
+        <p:txBody>
+          <a:bodyPr wrap="none">
+            <a:spAutoFit/>
+          </a:bodyPr>
+          <a:lstStyle/>
+          <a:p>
+            <a:pPr algn="ctr"/>
+            <a:r>
+              <a:rPr sz="1100" b="1">
+                <a:solidFill>
+                  <a:srgbClr val="B87020"/>
+                </a:solidFill>
+              </a:rPr>
+              <a:t>POP운영팀</a:t>
+            </a:r>
+          </a:p>
+        </p:txBody>
+      </p:sp>
+      <p:pic>
+        <p:nvPicPr>
+          <p:cNvPr id="28" name="Picture 27" descr="person_final_2.png"/>
+          <p:cNvPicPr>
+            <a:picLocks noChangeAspect="1"/>
+          </p:cNvPicPr>
+          <p:nvPr/>
+        </p:nvPicPr>
+        <p:blipFill>
+          <a:blip r:embed="rId6"/>
+          <a:stretch>
+            <a:fillRect/>
+          </a:stretch>
+        </p:blipFill>
+        <p:spPr>
+          <a:xfrm>
+            <a:off x="9052559" y="4754880"/>
+            <a:ext cx="1645920" cy="1645920"/>
+          </a:xfrm>
+          <a:prstGeom prst="rect">
+            <a:avLst/>
+          </a:prstGeom>
+        </p:spPr>
+      </p:pic>
+      <p:sp>
+        <p:nvSpPr>
+          <p:cNvPr id="29" name="TextBox 28"/>
+          <p:cNvSpPr txBox="1"/>
+          <p:nvPr/>
+        </p:nvSpPr>
+        <p:spPr>
+          <a:xfrm>
+            <a:off x="9235440" y="6537960"/>
+            <a:ext cx="1280160" cy="274320"/>
+          </a:xfrm>
+          <a:prstGeom prst="rect">
+            <a:avLst/>
+          </a:prstGeom>
+          <a:noFill/>
+        </p:spPr>
+        <p:txBody>
+          <a:bodyPr wrap="none">
+            <a:spAutoFit/>
+          </a:bodyPr>
+          <a:lstStyle/>
+          <a:p>
+            <a:pPr algn="ctr"/>
+            <a:r>
+              <a:rPr sz="2000" b="1">
+                <a:solidFill>
+                  <a:srgbClr val="2C1508"/>
+                </a:solidFill>
+              </a:rPr>
+              <a:t>제경순</a:t>
+            </a:r>
+          </a:p>
+        </p:txBody>
+      </p:sp>
+      <p:sp>
+        <p:nvSpPr>
+          <p:cNvPr id="30" name="TextBox 29"/>
+          <p:cNvSpPr txBox="1"/>
+          <p:nvPr/>
+        </p:nvSpPr>
+        <p:spPr>
+          <a:xfrm>
+            <a:off x="9235440" y="6858000"/>
+            <a:ext cx="1280160" cy="274320"/>
+          </a:xfrm>
+          <a:prstGeom prst="rect">
+            <a:avLst/>
+          </a:prstGeom>
+          <a:noFill/>
+        </p:spPr>
+        <p:txBody>
+          <a:bodyPr wrap="none">
+            <a:spAutoFit/>
+          </a:bodyPr>
+          <a:lstStyle/>
+          <a:p>
+            <a:pPr algn="ctr"/>
+            <a:r>
+              <a:rPr sz="1400" b="0">
+                <a:solidFill>
+                  <a:srgbClr val="9B7340"/>
+                </a:solidFill>
+              </a:rPr>
+              <a:t>파트너님</a:t>
+            </a:r>
+          </a:p>
+        </p:txBody>
+      </p:sp>
+      <p:sp>
+        <p:nvSpPr>
+          <p:cNvPr id="31" name="TextBox 30"/>
+          <p:cNvSpPr txBox="1"/>
+          <p:nvPr/>
+        </p:nvSpPr>
+        <p:spPr>
+          <a:xfrm>
+            <a:off x="9235440" y="7132320"/>
+            <a:ext cx="1280160" cy="274320"/>
+          </a:xfrm>
+          <a:prstGeom prst="rect">
+            <a:avLst/>
+          </a:prstGeom>
+          <a:noFill/>
+        </p:spPr>
+        <p:txBody>
+          <a:bodyPr wrap="none">
+            <a:spAutoFit/>
+          </a:bodyPr>
+          <a:lstStyle/>
+          <a:p>
+            <a:pPr algn="ctr"/>
+            <a:r>
+              <a:rPr sz="1300" b="1">
+                <a:solidFill>
+                  <a:srgbClr val="C9853A"/>
+                </a:solidFill>
+              </a:rPr>
+              <a:t>15년 8개월</a:t>
+            </a:r>
+          </a:p>
+        </p:txBody>
+      </p:sp>
+      <p:sp>
+        <p:nvSpPr>
+          <p:cNvPr id="32" name="TextBox 31"/>
+          <p:cNvSpPr txBox="1"/>
+          <p:nvPr/>
+        </p:nvSpPr>
+        <p:spPr>
+          <a:xfrm>
+            <a:off x="11887200" y="4343400"/>
+            <a:ext cx="1097280" cy="320040"/>
+          </a:xfrm>
+          <a:prstGeom prst="rect">
+            <a:avLst/>
+          </a:prstGeom>
+          <a:noFill/>
+        </p:spPr>
+        <p:txBody>
+          <a:bodyPr wrap="none">
+            <a:spAutoFit/>
+          </a:bodyPr>
+          <a:lstStyle/>
+          <a:p>
+            <a:pPr algn="ctr"/>
+            <a:r>
+              <a:rPr sz="1100" b="1">
+                <a:solidFill>
+                  <a:srgbClr val="B87020"/>
+                </a:solidFill>
+              </a:rPr>
+              <a:t>식품팀</a:t>
+            </a:r>
+          </a:p>
+        </p:txBody>
+      </p:sp>
+      <p:pic>
+        <p:nvPicPr>
+          <p:cNvPr id="33" name="Picture 32" descr="person_final_2.png"/>
+          <p:cNvPicPr>
+            <a:picLocks noChangeAspect="1"/>
+          </p:cNvPicPr>
+          <p:nvPr/>
+        </p:nvPicPr>
+        <p:blipFill>
+          <a:blip r:embed="rId6"/>
+          <a:stretch>
+            <a:fillRect/>
+          </a:stretch>
+        </p:blipFill>
+        <p:spPr>
+          <a:xfrm>
+            <a:off x="11612880" y="4754880"/>
+            <a:ext cx="1645920" cy="1645920"/>
+          </a:xfrm>
+          <a:prstGeom prst="rect">
+            <a:avLst/>
+          </a:prstGeom>
+        </p:spPr>
+      </p:pic>
+      <p:sp>
+        <p:nvSpPr>
+          <p:cNvPr id="34" name="TextBox 33"/>
+          <p:cNvSpPr txBox="1"/>
+          <p:nvPr/>
+        </p:nvSpPr>
+        <p:spPr>
+          <a:xfrm>
+            <a:off x="11795760" y="6537960"/>
+            <a:ext cx="1280160" cy="274320"/>
+          </a:xfrm>
+          <a:prstGeom prst="rect">
+            <a:avLst/>
+          </a:prstGeom>
+          <a:noFill/>
+        </p:spPr>
+        <p:txBody>
+          <a:bodyPr wrap="none">
+            <a:spAutoFit/>
+          </a:bodyPr>
+          <a:lstStyle/>
+          <a:p>
+            <a:pPr algn="ctr"/>
+            <a:r>
+              <a:rPr sz="2000" b="1">
                 <a:solidFill>
                   <a:srgbClr val="2C1508"/>
                 </a:solidFill>
@@ -4033,14 +4210,14 @@
       </p:sp>
       <p:sp>
         <p:nvSpPr>
-          <p:cNvPr id="30" name="TextBox 29"/>
+          <p:cNvPr id="35" name="TextBox 34"/>
           <p:cNvSpPr txBox="1"/>
           <p:nvPr/>
         </p:nvSpPr>
         <p:spPr>
           <a:xfrm>
-            <a:off x="9281160" y="6126480"/>
-            <a:ext cx="1645920" cy="274320"/>
+            <a:off x="11795760" y="6858000"/>
+            <a:ext cx="1280160" cy="274320"/>
           </a:xfrm>
           <a:prstGeom prst="rect">
             <a:avLst/>
@@ -4055,7 +4232,7 @@
           <a:p>
             <a:pPr algn="ctr"/>
             <a:r>
-              <a:rPr sz="1300" b="0">
+              <a:rPr sz="1400" b="0">
                 <a:solidFill>
                   <a:srgbClr val="9B7340"/>
                 </a:solidFill>
@@ -4067,14 +4244,14 @@
       </p:sp>
       <p:sp>
         <p:nvSpPr>
-          <p:cNvPr id="31" name="TextBox 30"/>
+          <p:cNvPr id="36" name="TextBox 35"/>
           <p:cNvSpPr txBox="1"/>
           <p:nvPr/>
         </p:nvSpPr>
         <p:spPr>
           <a:xfrm>
-            <a:off x="9281160" y="6355080"/>
-            <a:ext cx="1645920" cy="274320"/>
+            <a:off x="11795760" y="7132320"/>
+            <a:ext cx="1280160" cy="274320"/>
           </a:xfrm>
           <a:prstGeom prst="rect">
             <a:avLst/>
@@ -4089,7 +4266,7 @@
           <a:p>
             <a:pPr algn="ctr"/>
             <a:r>
-              <a:rPr sz="1200" b="1">
+              <a:rPr sz="1300" b="1">
                 <a:solidFill>
                   <a:srgbClr val="C9853A"/>
                 </a:solidFill>

</xml_diff>